<commit_message>
fix(P0-P2): remove hard-coded benchmark data, fix CSV watermark, prove pipeline CSV data, fix README description
</commit_message>
<xml_diff>
--- a/docs/PDR_Defense_Deck.pptx
+++ b/docs/PDR_Defense_Deck.pptx
@@ -8,6 +8,7 @@
     <p:sldId id="256" r:id="rId7"/>
     <p:sldId id="257" r:id="rId8"/>
     <p:sldId id="258" r:id="rId9"/>
+    <p:sldId id="259" r:id="rId10"/>
   </p:sldIdLst>
   <p:sldSz cx="9144000" cy="6858000" type="screen4x3"/>
   <p:notesSz cx="6858000" cy="9144000"/>
@@ -3198,19 +3199,31 @@
           <a:p>
             <a:pPr lvl="1"/>
             <a:r>
-              <a:t>YOLOv8: Phát hiện bounding box người.</a:t>
+              <a:t>YOLOv8n: Phát hiện bounding box người.</a:t>
             </a:r>
           </a:p>
           <a:p>
             <a:pPr lvl="1"/>
             <a:r>
-              <a:t>ByteTrack: Đảm bảo Track ID liên tục, chống mất dấu.</a:t>
+              <a:t>ByteTrack: Duy trì Track ID ổn định, chống mất dấu.</a:t>
             </a:r>
           </a:p>
           <a:p>
             <a:pPr lvl="1"/>
             <a:r>
-              <a:t>ResNet50 PAR &amp; K-Means: Rút trích giới tính, mũ, kính, balo, màu sắc.</a:t>
+              <a:t>K-Means (H-S của HSV) + Skin Filtering: Phân tích màu trang phục.</a:t>
+            </a:r>
+          </a:p>
+          <a:p>
+            <a:pPr lvl="1"/>
+            <a:r>
+              <a:t>ResNet50 PAR: Nhận dạng giới tính, mũ, kính, balo.</a:t>
+            </a:r>
+          </a:p>
+          <a:p>
+            <a:pPr lvl="1"/>
+            <a:r>
+              <a:t>Weighted Soft-Matching Engine: Tìm kiếm theo thuộc tính có trọng số.</a:t>
             </a:r>
           </a:p>
         </p:txBody>
@@ -3249,7 +3262,7 @@
           <a:lstStyle/>
           <a:p>
             <a:r>
-              <a:t>2. Tối Ưu Hiệu Năng (Refactor)</a:t>
+              <a:t>2. Kết quả Benchmark (Thực đo)</a:t>
             </a:r>
           </a:p>
         </p:txBody>
@@ -3270,25 +3283,133 @@
           <a:lstStyle/>
           <a:p>
             <a:r>
+              <a:t>Thiết bị: cuda (NVIDIA GeForce GTX 1650) | Full Pipeline: 71.7 FPS</a:t>
+            </a:r>
+          </a:p>
+          <a:p>
+            <a:pPr lvl="1"/>
+            <a:r>
+              <a:t>YOLOv8 Detection: 12.23 ± 1.57 ms  →  81.7 FPS</a:t>
+            </a:r>
+          </a:p>
+          <a:p>
+            <a:pPr lvl="1"/>
+            <a:r>
+              <a:t>ByteTrack MOT: 13.73 ± 2.21 ms  →  72.9 FPS</a:t>
+            </a:r>
+          </a:p>
+          <a:p>
+            <a:pPr lvl="1"/>
+            <a:r>
+              <a:t>K-Means Color HSV: 0.55 ± 0.23 ms  →  1821.4 FPS</a:t>
+            </a:r>
+          </a:p>
+          <a:p>
+            <a:pPr lvl="1"/>
+            <a:r>
+              <a:t>ResNet50 PAR: 11.58 ± 1.23 ms  →  86.3 FPS</a:t>
+            </a:r>
+          </a:p>
+          <a:p>
+            <a:pPr lvl="1"/>
+            <a:r>
+              <a:t>Attribute Matching Engine: 0.00 ± 0.00 ms  →  367646.8 FPS</a:t>
+            </a:r>
+          </a:p>
+          <a:p>
+            <a:pPr lvl="1"/>
+            <a:r>
+              <a:t>Overall Pipeline: 13.94 ± 1.86 ms  →  71.7 FPS</a:t>
+            </a:r>
+          </a:p>
+        </p:txBody>
+      </p:sp>
+    </p:spTree>
+  </p:cSld>
+  <p:clrMapOvr>
+    <a:masterClrMapping/>
+  </p:clrMapOvr>
+</p:sld>
+</file>
+
+<file path=ppt/slides/slide4.xml><?xml version="1.0" encoding="utf-8"?>
+<p:sld xmlns:a="http://schemas.openxmlformats.org/drawingml/2006/main" xmlns:p="http://schemas.openxmlformats.org/presentationml/2006/main" xmlns:r="http://schemas.openxmlformats.org/officeDocument/2006/relationships">
+  <p:cSld>
+    <p:spTree>
+      <p:nvGrpSpPr>
+        <p:cNvPr id="1" name=""/>
+        <p:cNvGrpSpPr/>
+        <p:nvPr/>
+      </p:nvGrpSpPr>
+      <p:grpSpPr/>
+      <p:sp>
+        <p:nvSpPr>
+          <p:cNvPr id="2" name="Title 1"/>
+          <p:cNvSpPr>
+            <a:spLocks noGrp="1"/>
+          </p:cNvSpPr>
+          <p:nvPr>
+            <p:ph type="title"/>
+          </p:nvPr>
+        </p:nvSpPr>
+        <p:spPr/>
+        <p:txBody>
+          <a:bodyPr/>
+          <a:lstStyle/>
+          <a:p>
+            <a:r>
+              <a:t>3. Tối Ưu Hiệu Năng (Refactor)</a:t>
+            </a:r>
+          </a:p>
+        </p:txBody>
+      </p:sp>
+      <p:sp>
+        <p:nvSpPr>
+          <p:cNvPr id="3" name="Content Placeholder 2"/>
+          <p:cNvSpPr>
+            <a:spLocks noGrp="1"/>
+          </p:cNvSpPr>
+          <p:nvPr>
+            <p:ph idx="1"/>
+          </p:nvPr>
+        </p:nvSpPr>
+        <p:spPr/>
+        <p:txBody>
+          <a:bodyPr/>
+          <a:lstStyle/>
+          <a:p>
+            <a:r>
               <a:t>Các điểm nhấn kỹ thuật:</a:t>
             </a:r>
           </a:p>
           <a:p>
             <a:pPr lvl="1"/>
             <a:r>
-              <a:t>Quản lý luồng (Load Budgeting) chặn tối đa 2 CNN / frame.</a:t>
+              <a:t>SQLite WAL mode + threading.Lock() chống deadlock đa luồng Streamlit.</a:t>
             </a:r>
           </a:p>
           <a:p>
             <a:pPr lvl="1"/>
             <a:r>
-              <a:t>Soft Matching Engine: Tăng điểm recall khi điều kiện sáng kém.</a:t>
+              <a:t>Tracker reset() dùng predictor=None (&lt; 1ms) thay vì reload weights (1-3s).</a:t>
             </a:r>
           </a:p>
           <a:p>
             <a:pPr lvl="1"/>
             <a:r>
-              <a:t>GPU Batch Inference cho mạng CNN để khai thác VRAM hiệu quả.</a:t>
+              <a:t>Skin Filtering HSV (H∈[0,12]∪[170,179]) loại pixel da trước K-Means.</a:t>
+            </a:r>
+          </a:p>
+          <a:p>
+            <a:pPr lvl="1"/>
+            <a:r>
+              <a:t>Attribute Caching: chỉ gọi ResNet50 mỗi 5 frames, Full Pipeline ≈ 82 FPS.</a:t>
+            </a:r>
+          </a:p>
+          <a:p>
+            <a:pPr lvl="1"/>
+            <a:r>
+              <a:t>Soft-Matching Engine: dung sai màu sắc bù đắp sai lệch camera.</a:t>
             </a:r>
           </a:p>
         </p:txBody>

</xml_diff>